<commit_message>
docs: aktualizacja GEMINI.md, INSTRUKCJA.md oraz automatyzacja brakujacych zrzutow w build_docs
</commit_message>
<xml_diff>
--- a/build_docs/Serial_Commander_Prezentacja.pptx
+++ b/build_docs/Serial_Commander_Prezentacja.pptx
@@ -16,6 +16,7 @@
     <p:sldId id="264" r:id="rId15"/>
     <p:sldId id="265" r:id="rId16"/>
     <p:sldId id="266" r:id="rId17"/>
+    <p:sldId id="267" r:id="rId18"/>
   </p:sldIdLst>
   <p:sldSz cx="12191695" cy="6858000" type="screen4x3"/>
   <p:notesSz cx="6858000" cy="9144000"/>
@@ -3136,7 +3137,7 @@
               </a:defRPr>
             </a:pPr>
             <a:r>
-              <a:t>1. Serial Commander v1.6 — Architektura i Główny Interfejs</a:t>
+              <a:t>1. Serial Commander v1.7 — Architektura i Główny Interfejs</a:t>
             </a:r>
           </a:p>
           <a:p>
@@ -3580,6 +3581,198 @@
 </p:sld>
 </file>
 
+<file path=ppt/slides/slide12.xml><?xml version="1.0" encoding="utf-8"?>
+<p:sld xmlns:a="http://schemas.openxmlformats.org/drawingml/2006/main" xmlns:p="http://schemas.openxmlformats.org/presentationml/2006/main" xmlns:r="http://schemas.openxmlformats.org/officeDocument/2006/relationships">
+  <p:cSld>
+    <p:bg>
+      <p:bgPr>
+        <a:solidFill>
+          <a:srgbClr val="18181B"/>
+        </a:solidFill>
+        <a:effectLst/>
+      </p:bgPr>
+    </p:bg>
+    <p:spTree>
+      <p:nvGrpSpPr>
+        <p:cNvPr id="1" name=""/>
+        <p:cNvGrpSpPr/>
+        <p:nvPr/>
+      </p:nvGrpSpPr>
+      <p:grpSpPr/>
+      <p:sp>
+        <p:nvSpPr>
+          <p:cNvPr id="2" name="TextBox 1"/>
+          <p:cNvSpPr txBox="1"/>
+          <p:nvPr/>
+        </p:nvSpPr>
+        <p:spPr>
+          <a:xfrm>
+            <a:off x="457200" y="182880"/>
+            <a:ext cx="11247120" cy="822960"/>
+          </a:xfrm>
+          <a:prstGeom prst="rect">
+            <a:avLst/>
+          </a:prstGeom>
+          <a:noFill/>
+        </p:spPr>
+        <p:txBody>
+          <a:bodyPr wrap="none">
+            <a:spAutoFit/>
+          </a:bodyPr>
+          <a:lstStyle/>
+          <a:p>
+            <a:pPr>
+              <a:defRPr sz="2200" b="1">
+                <a:solidFill>
+                  <a:srgbClr val="FFFFFF"/>
+                </a:solidFill>
+              </a:defRPr>
+            </a:pPr>
+            <a:r>
+              <a:t>12. Tryb Magistrali CAN (Adapter CANable / slcan)</a:t>
+            </a:r>
+          </a:p>
+          <a:p>
+            <a:pPr>
+              <a:defRPr sz="1300">
+                <a:solidFill>
+                  <a:srgbClr val="74C0FC"/>
+                </a:solidFill>
+              </a:defRPr>
+            </a:pPr>
+            <a:r>
+              <a:t>Obsługa protokołu CANable, wysyłanie ramek cansend oraz telemetria Live Watch z czasem cyklu Delta_t</a:t>
+            </a:r>
+          </a:p>
+        </p:txBody>
+      </p:sp>
+      <p:sp>
+        <p:nvSpPr>
+          <p:cNvPr id="3" name="TextBox 2"/>
+          <p:cNvSpPr txBox="1"/>
+          <p:nvPr/>
+        </p:nvSpPr>
+        <p:spPr>
+          <a:xfrm>
+            <a:off x="1097280" y="1005840"/>
+            <a:ext cx="9966960" cy="3657600"/>
+          </a:xfrm>
+          <a:prstGeom prst="rect">
+            <a:avLst/>
+          </a:prstGeom>
+          <a:noFill/>
+        </p:spPr>
+        <p:txBody>
+          <a:bodyPr wrap="square">
+            <a:spAutoFit/>
+          </a:bodyPr>
+          <a:lstStyle/>
+          <a:p>
+            <a:pPr>
+              <a:defRPr sz="1600" b="1">
+                <a:solidFill>
+                  <a:srgbClr val="FFD43B"/>
+                </a:solidFill>
+              </a:defRPr>
+            </a:pPr>
+            <a:r>
+              <a:t>📷 WYMAGANY NOWY ZRZUT EKRANU: zrzut_can_mode.png</a:t>
+            </a:r>
+          </a:p>
+          <a:p>
+            <a:br/>
+            <a:pPr>
+              <a:defRPr sz="1200">
+                <a:solidFill>
+                  <a:srgbClr val="C8C8C8"/>
+                </a:solidFill>
+              </a:defRPr>
+            </a:pPr>
+            <a:r>
+              <a:t>Wytyczne: Zrzut ekranu karty pracującej w trybie CAN: pasek z etykietą 'Bitrate: 500k', zielony wskaźnik połączenia '[ON] COM20 · CAN 500k', konsola z odebranymi ramkami CAN w formacie '187#01 02 03 04', panel Live Watch z posortowanymi wierszami CAN ID, wskaźnikami czasu cyklu 'Delta ... ms' oraz podświetlonymi (złotymi) zmienionymi bajtami. Na dole pole wprowadzania z placeholderem '187#01 02 03'.</a:t>
+            </a:r>
+          </a:p>
+        </p:txBody>
+      </p:sp>
+      <p:sp>
+        <p:nvSpPr>
+          <p:cNvPr id="4" name="TextBox 3"/>
+          <p:cNvSpPr txBox="1"/>
+          <p:nvPr/>
+        </p:nvSpPr>
+        <p:spPr>
+          <a:xfrm>
+            <a:off x="457200" y="4937760"/>
+            <a:ext cx="11247120" cy="1737360"/>
+          </a:xfrm>
+          <a:prstGeom prst="rect">
+            <a:avLst/>
+          </a:prstGeom>
+          <a:noFill/>
+        </p:spPr>
+        <p:txBody>
+          <a:bodyPr wrap="square">
+            <a:spAutoFit/>
+          </a:bodyPr>
+          <a:lstStyle/>
+          <a:p>
+            <a:pPr>
+              <a:defRPr sz="1100">
+                <a:solidFill>
+                  <a:srgbClr val="E4E4E7"/>
+                </a:solidFill>
+              </a:defRPr>
+            </a:pPr>
+            <a:r>
+              <a:t>• [1] Konfiguracja i Bitrate CAN: Wybór prędkości magistrali (10k - 1M) w profilu połączenia CANable slcan.</a:t>
+            </a:r>
+          </a:p>
+          <a:p>
+            <a:pPr>
+              <a:defRPr sz="1100">
+                <a:solidFill>
+                  <a:srgbClr val="E4E4E7"/>
+                </a:solidFill>
+              </a:defRPr>
+            </a:pPr>
+            <a:r>
+              <a:t>• [2] Sortowanie CAN ID i Czas Cyklu Delta_t: Wiersze Live Watch są automatycznie sortowane rosnąco po ID, z pomiarem odstępu czasowego Delta_t.</a:t>
+            </a:r>
+          </a:p>
+          <a:p>
+            <a:pPr>
+              <a:defRPr sz="1100">
+                <a:solidFill>
+                  <a:srgbClr val="E4E4E7"/>
+                </a:solidFill>
+              </a:defRPr>
+            </a:pPr>
+            <a:r>
+              <a:t>• [3] Błysk Zmienionych Bajtów: Zmienione wartości danych w ramce błyskają na złoto na 750 ms, pozwalając śledzić zmiany w locie.</a:t>
+            </a:r>
+          </a:p>
+          <a:p>
+            <a:pPr>
+              <a:defRPr sz="1100">
+                <a:solidFill>
+                  <a:srgbClr val="E4E4E7"/>
+                </a:solidFill>
+              </a:defRPr>
+            </a:pPr>
+            <a:r>
+              <a:t>• [4] Składnia cansend i Przyciski CAN: Nadawanie ramek standardowych i rozszerzonych w formacie 'ID#DANE' oraz obsługa ACK w przyciskach.</a:t>
+            </a:r>
+          </a:p>
+        </p:txBody>
+      </p:sp>
+    </p:spTree>
+  </p:cSld>
+  <p:clrMapOvr>
+    <a:masterClrMapping/>
+  </p:clrMapOvr>
+</p:sld>
+</file>
+
 <file path=ppt/slides/slide2.xml><?xml version="1.0" encoding="utf-8"?>
 <p:sld xmlns:a="http://schemas.openxmlformats.org/drawingml/2006/main" xmlns:p="http://schemas.openxmlformats.org/presentationml/2006/main" xmlns:r="http://schemas.openxmlformats.org/officeDocument/2006/relationships">
   <p:cSld>
@@ -3640,7 +3833,7 @@
               </a:defRPr>
             </a:pPr>
             <a:r>
-              <a:t>Kompaktowy widok w spoczynku oraz pełna identyfikacja sterowników po rozwinięciu listy</a:t>
+              <a:t>Kompaktowy widok w spoczynku, wykrywanie nowych portów oraz pełna identyfikacja sterowników</a:t>
             </a:r>
           </a:p>
         </p:txBody>
@@ -3711,7 +3904,7 @@
               </a:defRPr>
             </a:pPr>
             <a:r>
-              <a:t>• [2] Rozwinięta lista urządzeń: Automatycznie poszerza się do 320 px, pokazując pełną nazwę sterownika (np. STLink, CH343, FTDI).</a:t>
+              <a:t>• [2] Rozwinięta lista urządzeń: Poszerza się do 340 px, pokazując pełną nazwę sterownika, a nowo wykryte porty wyróżnia etykietą '✨ ... [NOWY]'.</a:t>
             </a:r>
           </a:p>
           <a:p>
@@ -3723,7 +3916,7 @@
               </a:defRPr>
             </a:pPr>
             <a:r>
-              <a:t>• [3] Odświeżanie portów (Odśwież): Błyskawiczne skanowanie nowo podłączonych konwerterów USB-UART bez restartu aplikacji.</a:t>
+              <a:t>• [3] Odświeżanie portów (Odśwież): Błyskawiczne skanowanie nowo podłączonych konwerterów USB-UART i CANable bez restartu aplikacji.</a:t>
             </a:r>
           </a:p>
           <a:p>

</xml_diff>

<commit_message>
feat(v1.7.2): blokada formatu CAN, przyklady click-to-clear i powiekszone pole makro
</commit_message>
<xml_diff>
--- a/build_docs/Serial_Commander_Prezentacja.pptx
+++ b/build_docs/Serial_Commander_Prezentacja.pptx
@@ -3760,7 +3760,7 @@
               </a:defRPr>
             </a:pPr>
             <a:r>
-              <a:t>• [4] Składnia cansend i Przyciski CAN: Nadawanie ramek standardowych i rozszerzonych w formacie 'ID#DANE' oraz obsługa ACK w przyciskach.</a:t>
+              <a:t>• [4] Przyciski CAN i Click-to-Clear: Zablokowany format TX na CAN, dynamiczne przykłady znikające po kliknięciu i powiększone pole Makro.</a:t>
             </a:r>
           </a:p>
         </p:txBody>
@@ -4228,7 +4228,7 @@
               </a:defRPr>
             </a:pPr>
             <a:r>
-              <a:t>• [2] 5 Trybów Pracy: Push (jednorazowy), Toggle (przełącznik ON/OFF), Hold (wciśnięty/puszczony), Trigger (pętla czasowa ms), Macro (sekwencja z sleep).</a:t>
+              <a:t>• [2] 5 Trybów Pracy: Push, Toggle (ACK), Hold, Trigger (pętla ms) oraz Macro (powiększone wieloliniowe pole sekwencji z sleep).</a:t>
             </a:r>
           </a:p>
           <a:p>

</xml_diff>

<commit_message>
feat(v1.8.0): akcje Query i Step, liczniki {CNT}, przycisk Stop oraz aktualizacja dokumentacji
- Typ przycisku Query (Request-Response z timeoutem i pomiarem czasu w ms)
- Typ przycisku Step (przełącznik wielostanowy z tabelą kroków)
- Dynamiczne liczniki kroczące {CNT} i {SEQ} z pomocnikiem szablonów i walidatorem CAN
- Przycisk Stop (N) zatrzymujący wszystkie aktywne pętle Trigger
- Aktualizacja INSTRUKCJA.md, build_docs.py (slajdy 12-13) oraz dołączenie zrzutów ekranu
</commit_message>
<xml_diff>
--- a/build_docs/Serial_Commander_Prezentacja.pptx
+++ b/build_docs/Serial_Commander_Prezentacja.pptx
@@ -17,6 +17,7 @@
     <p:sldId id="265" r:id="rId16"/>
     <p:sldId id="266" r:id="rId17"/>
     <p:sldId id="267" r:id="rId18"/>
+    <p:sldId id="268" r:id="rId19"/>
   </p:sldIdLst>
   <p:sldSz cx="12191695" cy="6858000" type="screen4x3"/>
   <p:notesSz cx="6858000" cy="9144000"/>
@@ -3137,7 +3138,7 @@
               </a:defRPr>
             </a:pPr>
             <a:r>
-              <a:t>1. Serial Commander v1.7 — Architektura i Główny Interfejs</a:t>
+              <a:t>1. Serial Commander v1.8 — Architektura i Główny Interfejs</a:t>
             </a:r>
           </a:p>
           <a:p>
@@ -3544,7 +3545,7 @@
               </a:defRPr>
             </a:pPr>
             <a:r>
-              <a:t>• [1] &amp; [2] Rozwinięte panele na skrajach w Split View: Pełny dostęp do 20 przycisków szybkich akcji jednocześnie przy zachowaniu sąsiadujących konsol w centrum.</a:t>
+              <a:t>• [1] Lewy panel 10 akcji: Rozwinięty przy lewej krawędzi okna z bezpośrednim dostępem do makr lewej karty.</a:t>
             </a:r>
           </a:p>
           <a:p>
@@ -3556,7 +3557,7 @@
               </a:defRPr>
             </a:pPr>
             <a:r>
-              <a:t>• [3] Zarządzanie Profilami (cfg/*.json): Automatyczny, atomowy zapis konfiguracji portu, przycisków, filtrów i przypięć Live Watch dla każdego urządzenia.</a:t>
+              <a:t>• [2] Prawy panel 10 akcji: Rozwinięty przy prawej krawędzi okna, pozostawiając obie konsole bezpośrednio obok siebie w centrum.</a:t>
             </a:r>
           </a:p>
           <a:p>
@@ -3568,7 +3569,19 @@
               </a:defRPr>
             </a:pPr>
             <a:r>
-              <a:t>• [4] Eksport Logów (HTML / MD / TXT) i Markery: Zapis przebiegu sesji z metryczką diagnostyczną (Data, Wersja, Port) i pełnym zachowaniem kolorów w formacie HTML/MD.</a:t>
+              <a:t>• [3] Zarządzanie profilami (cfg/*.json): Niezależny wybór i atomowy zapis konfiguracji dla każdej z kart.</a:t>
+            </a:r>
+          </a:p>
+          <a:p>
+            <a:pPr>
+              <a:defRPr sz="1100">
+                <a:solidFill>
+                  <a:srgbClr val="E4E4E7"/>
+                </a:solidFill>
+              </a:defRPr>
+            </a:pPr>
+            <a:r>
+              <a:t>• [4] Eksport Logów i Markery: Zapis przebiegu sesji (przycisk '💾 Zapisz Logi') do HTML (z kolorami), Markdown oraz TXT.</a:t>
             </a:r>
           </a:p>
         </p:txBody>
@@ -3646,16 +3659,40 @@
           </a:p>
         </p:txBody>
       </p:sp>
-      <p:sp>
-        <p:nvSpPr>
-          <p:cNvPr id="3" name="TextBox 2"/>
+      <p:pic>
+        <p:nvPicPr>
+          <p:cNvPr id="3" name="Picture 2" descr="slide_12.png"/>
+          <p:cNvPicPr>
+            <a:picLocks noChangeAspect="1"/>
+          </p:cNvPicPr>
+          <p:nvPr/>
+        </p:nvPicPr>
+        <p:blipFill>
+          <a:blip r:embed="rId2"/>
+          <a:stretch>
+            <a:fillRect/>
+          </a:stretch>
+        </p:blipFill>
+        <p:spPr>
+          <a:xfrm>
+            <a:off x="1097280" y="1005840"/>
+            <a:ext cx="5061742" cy="3840480"/>
+          </a:xfrm>
+          <a:prstGeom prst="rect">
+            <a:avLst/>
+          </a:prstGeom>
+        </p:spPr>
+      </p:pic>
+      <p:sp>
+        <p:nvSpPr>
+          <p:cNvPr id="4" name="TextBox 3"/>
           <p:cNvSpPr txBox="1"/>
           <p:nvPr/>
         </p:nvSpPr>
         <p:spPr>
           <a:xfrm>
-            <a:off x="1097280" y="1005840"/>
-            <a:ext cx="9966960" cy="3657600"/>
+            <a:off x="457200" y="4937760"/>
+            <a:ext cx="11247120" cy="1737360"/>
           </a:xfrm>
           <a:prstGeom prst="rect">
             <a:avLst/>
@@ -3669,41 +3706,90 @@
           <a:lstStyle/>
           <a:p>
             <a:pPr>
-              <a:defRPr sz="1600" b="1">
-                <a:solidFill>
-                  <a:srgbClr val="FFD43B"/>
-                </a:solidFill>
-              </a:defRPr>
-            </a:pPr>
-            <a:r>
-              <a:t>📷 WYMAGANY NOWY ZRZUT EKRANU: zrzut_can_mode.png</a:t>
-            </a:r>
-          </a:p>
-          <a:p>
-            <a:br/>
-            <a:pPr>
-              <a:defRPr sz="1200">
-                <a:solidFill>
-                  <a:srgbClr val="C8C8C8"/>
-                </a:solidFill>
-              </a:defRPr>
-            </a:pPr>
-            <a:r>
-              <a:t>Wytyczne: Zrzut ekranu karty pracującej w trybie CAN: pasek z etykietą 'Bitrate: 500k', zielony wskaźnik połączenia '[ON] COM20 · CAN 500k', konsola z odebranymi ramkami CAN w formacie '187#01 02 03 04', panel Live Watch z posortowanymi wierszami CAN ID, wskaźnikami czasu cyklu 'Delta ... ms' oraz podświetlonymi (złotymi) zmienionymi bajtami. Na dole pole wprowadzania z placeholderem '187#01 02 03'.</a:t>
-            </a:r>
-          </a:p>
-        </p:txBody>
-      </p:sp>
-      <p:sp>
-        <p:nvSpPr>
-          <p:cNvPr id="4" name="TextBox 3"/>
+              <a:defRPr sz="1100">
+                <a:solidFill>
+                  <a:srgbClr val="E4E4E7"/>
+                </a:solidFill>
+              </a:defRPr>
+            </a:pPr>
+            <a:r>
+              <a:t>• [1] Konfiguracja i Bitrate CAN: Wybór prędkości magistrali (10k do 1M) w profilu połączenia CANable slcan.</a:t>
+            </a:r>
+          </a:p>
+          <a:p>
+            <a:pPr>
+              <a:defRPr sz="1100">
+                <a:solidFill>
+                  <a:srgbClr val="E4E4E7"/>
+                </a:solidFill>
+              </a:defRPr>
+            </a:pPr>
+            <a:r>
+              <a:t>• [2] Sortowanie CAN ID i Czas Cyklu (Δt): Wiersze Live Watch są uporządkowane rosnąco po ID z precyzyjnym pomiarem czasu cyklu (np. Δ 11 ms).</a:t>
+            </a:r>
+          </a:p>
+          <a:p>
+            <a:pPr>
+              <a:defRPr sz="1100">
+                <a:solidFill>
+                  <a:srgbClr val="E4E4E7"/>
+                </a:solidFill>
+              </a:defRPr>
+            </a:pPr>
+            <a:r>
+              <a:t>• [3] Błysk Zmienionych Bajtów: Zmienione wartości w ramce CAN podświetlają się na złoto przez 750 ms, ułatwiając detekcję zmian.</a:t>
+            </a:r>
+          </a:p>
+          <a:p>
+            <a:pPr>
+              <a:defRPr sz="1100">
+                <a:solidFill>
+                  <a:srgbClr val="E4E4E7"/>
+                </a:solidFill>
+              </a:defRPr>
+            </a:pPr>
+            <a:r>
+              <a:t>• [4] Nadawanie Ramek CAN (cansend): Wprowadzanie ramek w składni ID#DANE (np. 187#01 02 03), ramek RTR (65A#R) oraz DLC=0 bezpośrednio z dolnego terminala.</a:t>
+            </a:r>
+          </a:p>
+        </p:txBody>
+      </p:sp>
+    </p:spTree>
+  </p:cSld>
+  <p:clrMapOvr>
+    <a:masterClrMapping/>
+  </p:clrMapOvr>
+</p:sld>
+</file>
+
+<file path=ppt/slides/slide13.xml><?xml version="1.0" encoding="utf-8"?>
+<p:sld xmlns:a="http://schemas.openxmlformats.org/drawingml/2006/main" xmlns:p="http://schemas.openxmlformats.org/presentationml/2006/main" xmlns:r="http://schemas.openxmlformats.org/officeDocument/2006/relationships">
+  <p:cSld>
+    <p:bg>
+      <p:bgPr>
+        <a:solidFill>
+          <a:srgbClr val="18181B"/>
+        </a:solidFill>
+        <a:effectLst/>
+      </p:bgPr>
+    </p:bg>
+    <p:spTree>
+      <p:nvGrpSpPr>
+        <p:cNvPr id="1" name=""/>
+        <p:cNvGrpSpPr/>
+        <p:nvPr/>
+      </p:nvGrpSpPr>
+      <p:grpSpPr/>
+      <p:sp>
+        <p:nvSpPr>
+          <p:cNvPr id="2" name="TextBox 1"/>
           <p:cNvSpPr txBox="1"/>
           <p:nvPr/>
         </p:nvSpPr>
         <p:spPr>
           <a:xfrm>
-            <a:off x="457200" y="4937760"/>
-            <a:ext cx="11247120" cy="1737360"/>
+            <a:off x="457200" y="182880"/>
+            <a:ext cx="11247120" cy="822960"/>
           </a:xfrm>
           <a:prstGeom prst="rect">
             <a:avLst/>
@@ -3711,6 +3797,77 @@
           <a:noFill/>
         </p:spPr>
         <p:txBody>
+          <a:bodyPr wrap="none">
+            <a:spAutoFit/>
+          </a:bodyPr>
+          <a:lstStyle/>
+          <a:p>
+            <a:pPr>
+              <a:defRPr sz="2200" b="1">
+                <a:solidFill>
+                  <a:srgbClr val="FFFFFF"/>
+                </a:solidFill>
+              </a:defRPr>
+            </a:pPr>
+            <a:r>
+              <a:t>13. Zaawansowane Przyciski (Query, Step), Licznik {CNT} i Stop Pętli</a:t>
+            </a:r>
+          </a:p>
+          <a:p>
+            <a:pPr>
+              <a:defRPr sz="1300">
+                <a:solidFill>
+                  <a:srgbClr val="74C0FC"/>
+                </a:solidFill>
+              </a:defRPr>
+            </a:pPr>
+            <a:r>
+              <a:t>Zapytania z timeoutem, stany krokowe, liczniki kroczące oraz natychmiastowe zatrzymanie pętli</a:t>
+            </a:r>
+          </a:p>
+        </p:txBody>
+      </p:sp>
+      <p:pic>
+        <p:nvPicPr>
+          <p:cNvPr id="3" name="Picture 2" descr="slide_13.png"/>
+          <p:cNvPicPr>
+            <a:picLocks noChangeAspect="1"/>
+          </p:cNvPicPr>
+          <p:nvPr/>
+        </p:nvPicPr>
+        <p:blipFill>
+          <a:blip r:embed="rId2"/>
+          <a:stretch>
+            <a:fillRect/>
+          </a:stretch>
+        </p:blipFill>
+        <p:spPr>
+          <a:xfrm>
+            <a:off x="1097280" y="1005840"/>
+            <a:ext cx="5101611" cy="3840480"/>
+          </a:xfrm>
+          <a:prstGeom prst="rect">
+            <a:avLst/>
+          </a:prstGeom>
+        </p:spPr>
+      </p:pic>
+      <p:sp>
+        <p:nvSpPr>
+          <p:cNvPr id="4" name="TextBox 3"/>
+          <p:cNvSpPr txBox="1"/>
+          <p:nvPr/>
+        </p:nvSpPr>
+        <p:spPr>
+          <a:xfrm>
+            <a:off x="457200" y="4937760"/>
+            <a:ext cx="11247120" cy="1737360"/>
+          </a:xfrm>
+          <a:prstGeom prst="rect">
+            <a:avLst/>
+          </a:prstGeom>
+          <a:noFill/>
+        </p:spPr>
+        <p:txBody>
           <a:bodyPr wrap="square">
             <a:spAutoFit/>
           </a:bodyPr>
@@ -3724,7 +3881,7 @@
               </a:defRPr>
             </a:pPr>
             <a:r>
-              <a:t>• [1] Konfiguracja i Bitrate CAN: Wybór prędkości magistrali (10k - 1M) w profilu połączenia CANable slcan.</a:t>
+              <a:t>• [1] Typ Query (Request-Response): Wysyła zapytanie i oczekuje na wzorzec w czasie Timeout. Sukces = zielony [OK] z czasem reakcji w ms, błąd = czerwony [TIMEOUT].</a:t>
             </a:r>
           </a:p>
           <a:p>
@@ -3736,7 +3893,7 @@
               </a:defRPr>
             </a:pPr>
             <a:r>
-              <a:t>• [2] Sortowanie CAN ID i Czas Cyklu Delta_t: Wiersze Live Watch są automatycznie sortowane rosnąco po ID, z pomiarem odstępu czasowego Delta_t.</a:t>
+              <a:t>• [2] Typ Step (Przełącznik Wielostanowy): Każde kliknięcie przełącza kolejny zdefiniowany krok (1..N) i natychmiast wysyła przypisany payload.</a:t>
             </a:r>
           </a:p>
           <a:p>
@@ -3748,7 +3905,7 @@
               </a:defRPr>
             </a:pPr>
             <a:r>
-              <a:t>• [3] Błysk Zmienionych Bajtów: Zmienione wartości danych w ramce błyskają na złoto na 750 ms, pozwalając śledzić zmiany w locie.</a:t>
+              <a:t>• [3] Przycisk '⏹ Stop (N)': Pojawia się w nagłówku panelu akcji przy aktywnych pętlach Trigger i jednym kliknięciem zatrzymuje wszystkie nadające timery.</a:t>
             </a:r>
           </a:p>
           <a:p>
@@ -3760,7 +3917,7 @@
               </a:defRPr>
             </a:pPr>
             <a:r>
-              <a:t>• [4] Przyciski CAN i Click-to-Clear: Zablokowany format TX na CAN, dynamiczne przykłady znikające po kliknięciu i powiększone pole Makro.</a:t>
+              <a:t>• [4] Pomocnik Liczników {CNT} i Walidator Live: Szybkie wstawianie szablonów ({CNT:00-FF:X}, 0{CNT:0-15:X}), podgląd wygenerowanej ramki w czasie rzeczywistym oraz przycisk automatycznej naprawy składni CAN.</a:t>
             </a:r>
           </a:p>
         </p:txBody>
@@ -4157,7 +4314,7 @@
               </a:defRPr>
             </a:pPr>
             <a:r>
-              <a:t>5 typów przycisków sterujących oraz inteligentna weryfikacja wykonania rozkazu przez sprzęt</a:t>
+              <a:t>7 typów przycisków sterujących, potwierdzenia ACK, zapytania z timeoutem i stany krokowe</a:t>
             </a:r>
           </a:p>
         </p:txBody>
@@ -4228,7 +4385,7 @@
               </a:defRPr>
             </a:pPr>
             <a:r>
-              <a:t>• [2] 5 Trybów Pracy: Push, Toggle (ACK), Hold, Trigger (pętla ms) oraz Macro (powiększone wieloliniowe pole sekwencji z sleep).</a:t>
+              <a:t>• [2] 7 Trybów Pracy: Push, Toggle (ACK), Hold, Trigger (pętla ms), Macro (sekwencje), Query (zapytanie z timeoutem) oraz Step (przełącznik wielostanowy).</a:t>
             </a:r>
           </a:p>
           <a:p>
@@ -5044,7 +5201,7 @@
               </a:defRPr>
             </a:pPr>
             <a:r>
-              <a:t>• [1] Sztywna symetria 50% / 50%: Obie karty mają zawsze identyczną szerokość co do piksela, niezależnie od włączonych kontrolek czy ostrzeżenia ZAPORA.</a:t>
+              <a:t>• [1] Sztywna symetria 50% / 50%: Obie karty mają zawsze identyczną szerokość co do piksela, niezależnie od kontrolek czy ostrzeżenia ZAPORA.</a:t>
             </a:r>
           </a:p>
           <a:p>
@@ -5056,7 +5213,7 @@
               </a:defRPr>
             </a:pPr>
             <a:r>
-              <a:t>• [2] &amp; [3] Skrajne rozmieszczenie przycisków Akcji: Przyciski rozwijania paneli bocznych ('▶ Akcje' i 'Akcje ◀') lądują na zewnętrznych krawędziach okna.</a:t>
+              <a:t>• [2] Lewy panel szybkich akcji: Przycisk '▶ Akcje' umieszczony na lewym, zewnętrznym skraju karty, nie zaburzając widoku konsoli.</a:t>
             </a:r>
           </a:p>
           <a:p>
@@ -5068,7 +5225,19 @@
               </a:defRPr>
             </a:pPr>
             <a:r>
-              <a:t>• [4] Automatyczne skalowanie okna: Wejście w Split View rozszerza okno do 1440 px, a kliknięcie 'Widok zakładek (1 okno)' zmniejsza je z powrotem do 940 px.</a:t>
+              <a:t>• [3] Prawy panel szybkich akcji: Przycisk 'Akcje ◀' umieszczony symetrycznie na prawym, zewnętrznym skraju karty.</a:t>
+            </a:r>
+          </a:p>
+          <a:p>
+            <a:pPr>
+              <a:defRPr sz="1100">
+                <a:solidFill>
+                  <a:srgbClr val="E4E4E7"/>
+                </a:solidFill>
+              </a:defRPr>
+            </a:pPr>
+            <a:r>
+              <a:t>• [4] Powrót do 1 okna i skalowanie: Kliknięcie 'Widok zakładek (1 okno)' przywraca klasyczne karty i zmniejsza szerokość okna do 940 px.</a:t>
             </a:r>
           </a:p>
         </p:txBody>

</xml_diff>

<commit_message>
feat(v1.9.0): pełna obsługa CAN FD (candleLight / gs_usb), protokołu TLV oraz konfiguracji Sample Point
- Dodano natywne wsparcie dla adapterów candleLight / gs_usb (WinUSB / libusb) obok slcan
- Zaimplementowano hybrydową obsługę ramek Klasycznych CAN 2.0 (do 8 B) oraz CAN FD (do 64 B, BRS)
- Dodano kreator binarnych ramek TLV (ot_app_msg_tlv) do 64 B w edytorze przycisków
- Skonfigurowano domyślny Sample Point 80.0% (standard CiA 601-1 dla CAN FD) naprawiający komunikację 500k / 2M
- Dodano wybór Sample Point i dynamiczne blokowanie opcji CAN FD w ConfigEditDialog
- Naprawiono filtrowanie ramek echo TX w CanWorker oraz domyślne wyświetlanie ramek Live Watch w konsoli
- Dodano skrypty diagnostyczne (tests/step1-3), narzędzie Zadig oraz zaktualizowano INSTRUKCJA.md i prezentację
</commit_message>
<xml_diff>
--- a/build_docs/Serial_Commander_Prezentacja.pptx
+++ b/build_docs/Serial_Commander_Prezentacja.pptx
@@ -18,6 +18,9 @@
     <p:sldId id="266" r:id="rId17"/>
     <p:sldId id="267" r:id="rId18"/>
     <p:sldId id="268" r:id="rId19"/>
+    <p:sldId id="269" r:id="rId20"/>
+    <p:sldId id="270" r:id="rId21"/>
+    <p:sldId id="271" r:id="rId22"/>
   </p:sldIdLst>
   <p:sldSz cx="12191695" cy="6858000" type="screen4x3"/>
   <p:notesSz cx="6858000" cy="9144000"/>
@@ -3918,6 +3921,510 @@
             </a:pPr>
             <a:r>
               <a:t>• [4] Pomocnik Liczników {CNT} i Walidator Live: Szybkie wstawianie szablonów ({CNT:00-FF:X}, 0{CNT:0-15:X}), podgląd wygenerowanej ramki w czasie rzeczywistym oraz przycisk automatycznej naprawy składni CAN.</a:t>
+            </a:r>
+          </a:p>
+        </p:txBody>
+      </p:sp>
+    </p:spTree>
+  </p:cSld>
+  <p:clrMapOvr>
+    <a:masterClrMapping/>
+  </p:clrMapOvr>
+</p:sld>
+</file>
+
+<file path=ppt/slides/slide14.xml><?xml version="1.0" encoding="utf-8"?>
+<p:sld xmlns:a="http://schemas.openxmlformats.org/drawingml/2006/main" xmlns:p="http://schemas.openxmlformats.org/presentationml/2006/main" xmlns:r="http://schemas.openxmlformats.org/officeDocument/2006/relationships">
+  <p:cSld>
+    <p:bg>
+      <p:bgPr>
+        <a:solidFill>
+          <a:srgbClr val="18181B"/>
+        </a:solidFill>
+        <a:effectLst/>
+      </p:bgPr>
+    </p:bg>
+    <p:spTree>
+      <p:nvGrpSpPr>
+        <p:cNvPr id="1" name=""/>
+        <p:cNvGrpSpPr/>
+        <p:nvPr/>
+      </p:nvGrpSpPr>
+      <p:grpSpPr/>
+      <p:sp>
+        <p:nvSpPr>
+          <p:cNvPr id="2" name="TextBox 1"/>
+          <p:cNvSpPr txBox="1"/>
+          <p:nvPr/>
+        </p:nvSpPr>
+        <p:spPr>
+          <a:xfrm>
+            <a:off x="457200" y="182880"/>
+            <a:ext cx="11247120" cy="822960"/>
+          </a:xfrm>
+          <a:prstGeom prst="rect">
+            <a:avLst/>
+          </a:prstGeom>
+          <a:noFill/>
+        </p:spPr>
+        <p:txBody>
+          <a:bodyPr wrap="none">
+            <a:spAutoFit/>
+          </a:bodyPr>
+          <a:lstStyle/>
+          <a:p>
+            <a:pPr>
+              <a:defRPr sz="2200" b="1">
+                <a:solidFill>
+                  <a:srgbClr val="FFFFFF"/>
+                </a:solidFill>
+              </a:defRPr>
+            </a:pPr>
+            <a:r>
+              <a:t>14. Konfigurator Połączenia CAN / CAN FD (Adapter candleLight)</a:t>
+            </a:r>
+          </a:p>
+          <a:p>
+            <a:pPr>
+              <a:defRPr sz="1300">
+                <a:solidFill>
+                  <a:srgbClr val="74C0FC"/>
+                </a:solidFill>
+              </a:defRPr>
+            </a:pPr>
+            <a:r>
+              <a:t>Niezależna faza arbitrażu i danych BRS, bufor do 64B oraz nasłuch Listen-only</a:t>
+            </a:r>
+          </a:p>
+        </p:txBody>
+      </p:sp>
+      <p:pic>
+        <p:nvPicPr>
+          <p:cNvPr id="3" name="Picture 2" descr="slide_14.png"/>
+          <p:cNvPicPr>
+            <a:picLocks noChangeAspect="1"/>
+          </p:cNvPicPr>
+          <p:nvPr/>
+        </p:nvPicPr>
+        <p:blipFill>
+          <a:blip r:embed="rId2"/>
+          <a:stretch>
+            <a:fillRect/>
+          </a:stretch>
+        </p:blipFill>
+        <p:spPr>
+          <a:xfrm>
+            <a:off x="1097280" y="1005840"/>
+            <a:ext cx="4789001" cy="3840480"/>
+          </a:xfrm>
+          <a:prstGeom prst="rect">
+            <a:avLst/>
+          </a:prstGeom>
+        </p:spPr>
+      </p:pic>
+      <p:sp>
+        <p:nvSpPr>
+          <p:cNvPr id="4" name="TextBox 3"/>
+          <p:cNvSpPr txBox="1"/>
+          <p:nvPr/>
+        </p:nvSpPr>
+        <p:spPr>
+          <a:xfrm>
+            <a:off x="457200" y="4937760"/>
+            <a:ext cx="11247120" cy="1737360"/>
+          </a:xfrm>
+          <a:prstGeom prst="rect">
+            <a:avLst/>
+          </a:prstGeom>
+          <a:noFill/>
+        </p:spPr>
+        <p:txBody>
+          <a:bodyPr wrap="square">
+            <a:spAutoFit/>
+          </a:bodyPr>
+          <a:lstStyle/>
+          <a:p>
+            <a:pPr>
+              <a:defRPr sz="1100">
+                <a:solidFill>
+                  <a:srgbClr val="E4E4E7"/>
+                </a:solidFill>
+              </a:defRPr>
+            </a:pPr>
+            <a:r>
+              <a:t>• [1] Typ Połączenia candleLight (WinUSB): Natywna obsługa adapterów STM32G4 w przestrzeni użytkownika przez bibliotekę candle-api (protokół gs_usb).</a:t>
+            </a:r>
+          </a:p>
+          <a:p>
+            <a:pPr>
+              <a:defRPr sz="1100">
+                <a:solidFill>
+                  <a:srgbClr val="E4E4E7"/>
+                </a:solidFill>
+              </a:defRPr>
+            </a:pPr>
+            <a:r>
+              <a:t>• [2] Prędkość Arbitrażu (Nominal Bitrate): Standardowa prędkość fazy nagłówka i arbitrażu (np. 500 kbps, do 1 Mbps) dla zachowania kompatybilności z węzłami magistrali.</a:t>
+            </a:r>
+          </a:p>
+          <a:p>
+            <a:pPr>
+              <a:defRPr sz="1100">
+                <a:solidFill>
+                  <a:srgbClr val="E4E4E7"/>
+                </a:solidFill>
+              </a:defRPr>
+            </a:pPr>
+            <a:r>
+              <a:t>• [3] Szybka Faza Danych CAN FD (Data Bitrate): Aktywacja ramki do 64 bajtów oraz prędkości BRS do 2 Mbps, 4 Mbps lub 5 Mbps w fazie przesyłu danych.</a:t>
+            </a:r>
+          </a:p>
+          <a:p>
+            <a:pPr>
+              <a:defRPr sz="1100">
+                <a:solidFill>
+                  <a:srgbClr val="E4E4E7"/>
+                </a:solidFill>
+              </a:defRPr>
+            </a:pPr>
+            <a:r>
+              <a:t>• [4] Opcje Nasłuchu i Telemetria: Tryb Listen-only (brak nadawania ramek ACK) oraz automatyczne przechwytywanie i przypinanie każdego nowego identyfikatora do panelu Live Watch.</a:t>
+            </a:r>
+          </a:p>
+        </p:txBody>
+      </p:sp>
+    </p:spTree>
+  </p:cSld>
+  <p:clrMapOvr>
+    <a:masterClrMapping/>
+  </p:clrMapOvr>
+</p:sld>
+</file>
+
+<file path=ppt/slides/slide15.xml><?xml version="1.0" encoding="utf-8"?>
+<p:sld xmlns:a="http://schemas.openxmlformats.org/drawingml/2006/main" xmlns:p="http://schemas.openxmlformats.org/presentationml/2006/main" xmlns:r="http://schemas.openxmlformats.org/officeDocument/2006/relationships">
+  <p:cSld>
+    <p:bg>
+      <p:bgPr>
+        <a:solidFill>
+          <a:srgbClr val="18181B"/>
+        </a:solidFill>
+        <a:effectLst/>
+      </p:bgPr>
+    </p:bg>
+    <p:spTree>
+      <p:nvGrpSpPr>
+        <p:cNvPr id="1" name=""/>
+        <p:cNvGrpSpPr/>
+        <p:nvPr/>
+      </p:nvGrpSpPr>
+      <p:grpSpPr/>
+      <p:sp>
+        <p:nvSpPr>
+          <p:cNvPr id="2" name="TextBox 1"/>
+          <p:cNvSpPr txBox="1"/>
+          <p:nvPr/>
+        </p:nvSpPr>
+        <p:spPr>
+          <a:xfrm>
+            <a:off x="457200" y="182880"/>
+            <a:ext cx="11247120" cy="822960"/>
+          </a:xfrm>
+          <a:prstGeom prst="rect">
+            <a:avLst/>
+          </a:prstGeom>
+          <a:noFill/>
+        </p:spPr>
+        <p:txBody>
+          <a:bodyPr wrap="none">
+            <a:spAutoFit/>
+          </a:bodyPr>
+          <a:lstStyle/>
+          <a:p>
+            <a:pPr>
+              <a:defRPr sz="2200" b="1">
+                <a:solidFill>
+                  <a:srgbClr val="FFFFFF"/>
+                </a:solidFill>
+              </a:defRPr>
+            </a:pPr>
+            <a:r>
+              <a:t>15. Konfigurator Przycisku CAN / CAN FD i Szablony Ramek</a:t>
+            </a:r>
+          </a:p>
+          <a:p>
+            <a:pPr>
+              <a:defRPr sz="1300">
+                <a:solidFill>
+                  <a:srgbClr val="74C0FC"/>
+                </a:solidFill>
+              </a:defRPr>
+            </a:pPr>
+            <a:r>
+              <a:t>Wybór standardu (Classic / FD / TLV), pomocnik liczników {CNT} i weryfikacja poprawności</a:t>
+            </a:r>
+          </a:p>
+        </p:txBody>
+      </p:sp>
+      <p:pic>
+        <p:nvPicPr>
+          <p:cNvPr id="3" name="Picture 2" descr="slide_15.png"/>
+          <p:cNvPicPr>
+            <a:picLocks noChangeAspect="1"/>
+          </p:cNvPicPr>
+          <p:nvPr/>
+        </p:nvPicPr>
+        <p:blipFill>
+          <a:blip r:embed="rId2"/>
+          <a:stretch>
+            <a:fillRect/>
+          </a:stretch>
+        </p:blipFill>
+        <p:spPr>
+          <a:xfrm>
+            <a:off x="1097280" y="1005840"/>
+            <a:ext cx="4796723" cy="3840480"/>
+          </a:xfrm>
+          <a:prstGeom prst="rect">
+            <a:avLst/>
+          </a:prstGeom>
+        </p:spPr>
+      </p:pic>
+      <p:sp>
+        <p:nvSpPr>
+          <p:cNvPr id="4" name="TextBox 3"/>
+          <p:cNvSpPr txBox="1"/>
+          <p:nvPr/>
+        </p:nvSpPr>
+        <p:spPr>
+          <a:xfrm>
+            <a:off x="457200" y="4937760"/>
+            <a:ext cx="11247120" cy="1737360"/>
+          </a:xfrm>
+          <a:prstGeom prst="rect">
+            <a:avLst/>
+          </a:prstGeom>
+          <a:noFill/>
+        </p:spPr>
+        <p:txBody>
+          <a:bodyPr wrap="square">
+            <a:spAutoFit/>
+          </a:bodyPr>
+          <a:lstStyle/>
+          <a:p>
+            <a:pPr>
+              <a:defRPr sz="1100">
+                <a:solidFill>
+                  <a:srgbClr val="E4E4E7"/>
+                </a:solidFill>
+              </a:defRPr>
+            </a:pPr>
+            <a:r>
+              <a:t>• [1] Wybór Standardu Ramki CAN: Niezależne wymuszenie formatu dla każdego kafelka: Auto, Klasyczny CAN 2.0 (maks. 8B), CAN FD z BRS (do 64B), CAN FD bez BRS lub Struktura TLV.</a:t>
+            </a:r>
+          </a:p>
+          <a:p>
+            <a:pPr>
+              <a:defRPr sz="1100">
+                <a:solidFill>
+                  <a:srgbClr val="E4E4E7"/>
+                </a:solidFill>
+              </a:defRPr>
+            </a:pPr>
+            <a:r>
+              <a:t>• [2] Szablony Ramek i Konwerter Formatu: Błyskawiczne wstawianie gotowych wzorców (8B CAN 2.0, 64B CAN FD, TLV) oraz konwersja istniejącego payloadu do wybranego standardu.</a:t>
+            </a:r>
+          </a:p>
+          <a:p>
+            <a:pPr>
+              <a:defRPr sz="1100">
+                <a:solidFill>
+                  <a:srgbClr val="E4E4E7"/>
+                </a:solidFill>
+              </a:defRPr>
+            </a:pPr>
+            <a:r>
+              <a:t>• [3] Składnia Nadawcza cansend i Liczniki {CNT}: Standardowy format ID#DANE z opcją wstrzykiwania dynamicznych liczników kroczących {CNT:00-FF:X} (1B) lub 0{CNT:0-15:X} (półbajt).</a:t>
+            </a:r>
+          </a:p>
+          <a:p>
+            <a:pPr>
+              <a:defRPr sz="1100">
+                <a:solidFill>
+                  <a:srgbClr val="E4E4E7"/>
+                </a:solidFill>
+              </a:defRPr>
+            </a:pPr>
+            <a:r>
+              <a:t>• [4] Walidacja Live i Ochrona Standardu: Sprawdzanie poprawności składni, blokada nadmiarowych bajtów w trybie CAN 2.0 z inteligentnym przyciskiem automatycznej naprawy.</a:t>
+            </a:r>
+          </a:p>
+        </p:txBody>
+      </p:sp>
+    </p:spTree>
+  </p:cSld>
+  <p:clrMapOvr>
+    <a:masterClrMapping/>
+  </p:clrMapOvr>
+</p:sld>
+</file>
+
+<file path=ppt/slides/slide16.xml><?xml version="1.0" encoding="utf-8"?>
+<p:sld xmlns:a="http://schemas.openxmlformats.org/drawingml/2006/main" xmlns:p="http://schemas.openxmlformats.org/presentationml/2006/main" xmlns:r="http://schemas.openxmlformats.org/officeDocument/2006/relationships">
+  <p:cSld>
+    <p:bg>
+      <p:bgPr>
+        <a:solidFill>
+          <a:srgbClr val="18181B"/>
+        </a:solidFill>
+        <a:effectLst/>
+      </p:bgPr>
+    </p:bg>
+    <p:spTree>
+      <p:nvGrpSpPr>
+        <p:cNvPr id="1" name=""/>
+        <p:cNvGrpSpPr/>
+        <p:nvPr/>
+      </p:nvGrpSpPr>
+      <p:grpSpPr/>
+      <p:sp>
+        <p:nvSpPr>
+          <p:cNvPr id="2" name="TextBox 1"/>
+          <p:cNvSpPr txBox="1"/>
+          <p:nvPr/>
+        </p:nvSpPr>
+        <p:spPr>
+          <a:xfrm>
+            <a:off x="457200" y="182880"/>
+            <a:ext cx="11247120" cy="822960"/>
+          </a:xfrm>
+          <a:prstGeom prst="rect">
+            <a:avLst/>
+          </a:prstGeom>
+          <a:noFill/>
+        </p:spPr>
+        <p:txBody>
+          <a:bodyPr wrap="none">
+            <a:spAutoFit/>
+          </a:bodyPr>
+          <a:lstStyle/>
+          <a:p>
+            <a:pPr>
+              <a:defRPr sz="2200" b="1">
+                <a:solidFill>
+                  <a:srgbClr val="FFFFFF"/>
+                </a:solidFill>
+              </a:defRPr>
+            </a:pPr>
+            <a:r>
+              <a:t>16. Tryb Magistrali CAN FD, Protokół candleLight i Kreator TLV</a:t>
+            </a:r>
+          </a:p>
+          <a:p>
+            <a:pPr>
+              <a:defRPr sz="1300">
+                <a:solidFill>
+                  <a:srgbClr val="74C0FC"/>
+                </a:solidFill>
+              </a:defRPr>
+            </a:pPr>
+            <a:r>
+              <a:t>Obsługa CAN FD do 64B, Bit Rate Switch (BRS), binarna struktura TLV i kreator nadawania</a:t>
+            </a:r>
+          </a:p>
+        </p:txBody>
+      </p:sp>
+      <p:pic>
+        <p:nvPicPr>
+          <p:cNvPr id="3" name="Picture 2" descr="slide_16.png"/>
+          <p:cNvPicPr>
+            <a:picLocks noChangeAspect="1"/>
+          </p:cNvPicPr>
+          <p:nvPr/>
+        </p:nvPicPr>
+        <p:blipFill>
+          <a:blip r:embed="rId2"/>
+          <a:stretch>
+            <a:fillRect/>
+          </a:stretch>
+        </p:blipFill>
+        <p:spPr>
+          <a:xfrm>
+            <a:off x="1097280" y="1005840"/>
+            <a:ext cx="4800600" cy="3840480"/>
+          </a:xfrm>
+          <a:prstGeom prst="rect">
+            <a:avLst/>
+          </a:prstGeom>
+        </p:spPr>
+      </p:pic>
+      <p:sp>
+        <p:nvSpPr>
+          <p:cNvPr id="4" name="TextBox 3"/>
+          <p:cNvSpPr txBox="1"/>
+          <p:nvPr/>
+        </p:nvSpPr>
+        <p:spPr>
+          <a:xfrm>
+            <a:off x="457200" y="4937760"/>
+            <a:ext cx="11247120" cy="1737360"/>
+          </a:xfrm>
+          <a:prstGeom prst="rect">
+            <a:avLst/>
+          </a:prstGeom>
+          <a:noFill/>
+        </p:spPr>
+        <p:txBody>
+          <a:bodyPr wrap="square">
+            <a:spAutoFit/>
+          </a:bodyPr>
+          <a:lstStyle/>
+          <a:p>
+            <a:pPr>
+              <a:defRPr sz="1100">
+                <a:solidFill>
+                  <a:srgbClr val="E4E4E7"/>
+                </a:solidFill>
+              </a:defRPr>
+            </a:pPr>
+            <a:r>
+              <a:t>• [1] Tryb candleLight na Żywo: Aktywna karta CAN FD z bezpośrednim wskaźnikiem prędkości arbitrażu (Nominal: 500k) i podłączonym adapterem USB (WinUSB).</a:t>
+            </a:r>
+          </a:p>
+          <a:p>
+            <a:pPr>
+              <a:defRPr sz="1100">
+                <a:solidFill>
+                  <a:srgbClr val="E4E4E7"/>
+                </a:solidFill>
+              </a:defRPr>
+            </a:pPr>
+            <a:r>
+              <a:t>• [2] Przycisk Nadajnika (📦 TLV / CAN FD): Szybki dostęp do interaktywnego kreatora umieszczony bezpośrednio obok konsoli wprowadzania komend.</a:t>
+            </a:r>
+          </a:p>
+          <a:p>
+            <a:pPr>
+              <a:defRPr sz="1100">
+                <a:solidFill>
+                  <a:srgbClr val="E4E4E7"/>
+                </a:solidFill>
+              </a:defRPr>
+            </a:pPr>
+            <a:r>
+              <a:t>• [3] Kreator Ramek CAN FD / TLV: Konfiguracja ID, flag FD/BRS, automatyczne pakowanie w strukturę ot_app_msg_tlv (&lt;BH) oraz nadawanie jednorazowe i cykliczne (z okresem ms).</a:t>
+            </a:r>
+          </a:p>
+          <a:p>
+            <a:pPr>
+              <a:defRPr sz="1100">
+                <a:solidFill>
+                  <a:srgbClr val="E4E4E7"/>
+                </a:solidFill>
+              </a:defRPr>
+            </a:pPr>
+            <a:r>
+              <a:t>• [4] Telemetria Live Watch i Dekodowanie TLV: Błyskawiczny podgląd zdekodowanych pól TLV w konsoli, podświetlanie zmienionych danych i pomiar czasu cyklu Δt z dokładnością do ms.</a:t>
             </a:r>
           </a:p>
         </p:txBody>

</xml_diff>

<commit_message>
docs(v1.10.0): zrzut ekranu mostu UART -> CAN w dokumentacji
- Dodano zrzut build_docs/zrzut_uart_can_bridge.png (slajd 17, rozdział 12 INSTRUKCJA.md)
- Dopasowano położenie numerków adnotacji slajdu 17 do układu zrzutu
- Zregenerowano dokumentację PDF i prezentację PPTX
</commit_message>
<xml_diff>
--- a/build_docs/Serial_Commander_Prezentacja.pptx
+++ b/build_docs/Serial_Commander_Prezentacja.pptx
@@ -21,6 +21,7 @@
     <p:sldId id="269" r:id="rId20"/>
     <p:sldId id="270" r:id="rId21"/>
     <p:sldId id="271" r:id="rId22"/>
+    <p:sldId id="272" r:id="rId23"/>
   </p:sldIdLst>
   <p:sldSz cx="12191695" cy="6858000" type="screen4x3"/>
   <p:notesSz cx="6858000" cy="9144000"/>
@@ -4425,6 +4426,174 @@
             </a:pPr>
             <a:r>
               <a:t>• [4] Telemetria Live Watch i Dekodowanie TLV: Błyskawiczny podgląd zdekodowanych pól TLV w konsoli, podświetlanie zmienionych danych i pomiar czasu cyklu Δt z dokładnością do ms.</a:t>
+            </a:r>
+          </a:p>
+        </p:txBody>
+      </p:sp>
+    </p:spTree>
+  </p:cSld>
+  <p:clrMapOvr>
+    <a:masterClrMapping/>
+  </p:clrMapOvr>
+</p:sld>
+</file>
+
+<file path=ppt/slides/slide17.xml><?xml version="1.0" encoding="utf-8"?>
+<p:sld xmlns:a="http://schemas.openxmlformats.org/drawingml/2006/main" xmlns:p="http://schemas.openxmlformats.org/presentationml/2006/main" xmlns:r="http://schemas.openxmlformats.org/officeDocument/2006/relationships">
+  <p:cSld>
+    <p:bg>
+      <p:bgPr>
+        <a:solidFill>
+          <a:srgbClr val="18181B"/>
+        </a:solidFill>
+        <a:effectLst/>
+      </p:bgPr>
+    </p:bg>
+    <p:spTree>
+      <p:nvGrpSpPr>
+        <p:cNvPr id="1" name=""/>
+        <p:cNvGrpSpPr/>
+        <p:nvPr/>
+      </p:nvGrpSpPr>
+      <p:grpSpPr/>
+      <p:sp>
+        <p:nvSpPr>
+          <p:cNvPr id="2" name="TextBox 1"/>
+          <p:cNvSpPr txBox="1"/>
+          <p:nvPr/>
+        </p:nvSpPr>
+        <p:spPr>
+          <a:xfrm>
+            <a:off x="457200" y="182880"/>
+            <a:ext cx="11247120" cy="822960"/>
+          </a:xfrm>
+          <a:prstGeom prst="rect">
+            <a:avLst/>
+          </a:prstGeom>
+          <a:noFill/>
+        </p:spPr>
+        <p:txBody>
+          <a:bodyPr wrap="none">
+            <a:spAutoFit/>
+          </a:bodyPr>
+          <a:lstStyle/>
+          <a:p>
+            <a:pPr>
+              <a:defRPr sz="2200" b="1">
+                <a:solidFill>
+                  <a:srgbClr val="FFFFFF"/>
+                </a:solidFill>
+              </a:defRPr>
+            </a:pPr>
+            <a:r>
+              <a:t>17. Most UART → CAN (Nucleo can_uart_bridge)</a:t>
+            </a:r>
+          </a:p>
+          <a:p>
+            <a:pPr>
+              <a:defRPr sz="1300">
+                <a:solidFill>
+                  <a:srgbClr val="74C0FC"/>
+                </a:solidFill>
+              </a:defRPr>
+            </a:pPr>
+            <a:r>
+              <a:t>Ramki CAN / CAN FD przez port COM: pola ID + dane, wybór magistrali i standardu, konfiguracja CFG#</a:t>
+            </a:r>
+          </a:p>
+        </p:txBody>
+      </p:sp>
+      <p:pic>
+        <p:nvPicPr>
+          <p:cNvPr id="3" name="Picture 2" descr="slide_17.png"/>
+          <p:cNvPicPr>
+            <a:picLocks noChangeAspect="1"/>
+          </p:cNvPicPr>
+          <p:nvPr/>
+        </p:nvPicPr>
+        <p:blipFill>
+          <a:blip r:embed="rId2"/>
+          <a:stretch>
+            <a:fillRect/>
+          </a:stretch>
+        </p:blipFill>
+        <p:spPr>
+          <a:xfrm>
+            <a:off x="1097280" y="1005840"/>
+            <a:ext cx="5520050" cy="3840480"/>
+          </a:xfrm>
+          <a:prstGeom prst="rect">
+            <a:avLst/>
+          </a:prstGeom>
+        </p:spPr>
+      </p:pic>
+      <p:sp>
+        <p:nvSpPr>
+          <p:cNvPr id="4" name="TextBox 3"/>
+          <p:cNvSpPr txBox="1"/>
+          <p:nvPr/>
+        </p:nvSpPr>
+        <p:spPr>
+          <a:xfrm>
+            <a:off x="457200" y="4937760"/>
+            <a:ext cx="11247120" cy="1737360"/>
+          </a:xfrm>
+          <a:prstGeom prst="rect">
+            <a:avLst/>
+          </a:prstGeom>
+          <a:noFill/>
+        </p:spPr>
+        <p:txBody>
+          <a:bodyPr wrap="square">
+            <a:spAutoFit/>
+          </a:bodyPr>
+          <a:lstStyle/>
+          <a:p>
+            <a:pPr>
+              <a:defRPr sz="1100">
+                <a:solidFill>
+                  <a:srgbClr val="E4E4E7"/>
+                </a:solidFill>
+              </a:defRPr>
+            </a:pPr>
+            <a:r>
+              <a:t>• [1] Pole ID hex: 3 cyfry = 11-bit, 8 cyfr = 29-bit. Puste ID = pole danych jako pełne polecenie (CFG?, 321##1#01 02).</a:t>
+            </a:r>
+          </a:p>
+          <a:p>
+            <a:pPr>
+              <a:defRPr sz="1100">
+                <a:solidFill>
+                  <a:srgbClr val="E4E4E7"/>
+                </a:solidFill>
+              </a:defRPr>
+            </a:pPr>
+            <a:r>
+              <a:t>• [2] Pole danych: bajty hex (lub tekst w trybie TLV). Dymek pokazuje linię wysyłaną do Nucleo, błąd = czerwona ramka i brak wysyłki.</a:t>
+            </a:r>
+          </a:p>
+          <a:p>
+            <a:pPr>
+              <a:defRPr sz="1100">
+                <a:solidFill>
+                  <a:srgbClr val="E4E4E7"/>
+                </a:solidFill>
+              </a:defRPr>
+            </a:pPr>
+            <a:r>
+              <a:t>• [3] Przycisk 🚌: tryb UART→CAN, magistrala CAN1/CAN2, standard ramki (Auto/Classic/FD+BRS/FD/TLV), dialog CFG#, kreator ramek, CFG? i HELP.</a:t>
+            </a:r>
+          </a:p>
+          <a:p>
+            <a:pPr>
+              <a:defRPr sz="1100">
+                <a:solidFill>
+                  <a:srgbClr val="E4E4E7"/>
+                </a:solidFill>
+              </a:defRPr>
+            </a:pPr>
+            <a:r>
+              <a:t>• [4] Odpowiedzi mostu w konsoli: '-&gt; CAN1 OK' na zielono, 'ERR:' na czerwono, 'WARN' na pomarańczowo.</a:t>
             </a:r>
           </a:p>
         </p:txBody>

</xml_diff>